<commit_message>
Update amar engine structure.pptx
</commit_message>
<xml_diff>
--- a/docs/amar engine structure.pptx
+++ b/docs/amar engine structure.pptx
@@ -6824,8 +6824,8 @@
         </p:nvSpPr>
         <p:spPr>
           <a:xfrm>
-            <a:off x="2571750" y="5198169"/>
-            <a:ext cx="2731294" cy="369332"/>
+            <a:off x="2571750" y="5159521"/>
+            <a:ext cx="2731294" cy="646331"/>
           </a:xfrm>
           <a:prstGeom prst="rect">
             <a:avLst/>
@@ -6852,8 +6852,24 @@
             </a:r>
             <a:r>
               <a:rPr lang="zh-CN" altLang="en-US" dirty="0"/>
-              <a:t>的基石</a:t>
-            </a:r>
+              <a:t>的基石，</a:t>
+            </a:r>
+            <a:endParaRPr lang="en-US" altLang="zh-CN" dirty="0"/>
+          </a:p>
+          <a:p>
+            <a:r>
+              <a:rPr lang="zh-CN" altLang="en-US" dirty="0"/>
+              <a:t>可参考单独的</a:t>
+            </a:r>
+            <a:r>
+              <a:rPr lang="en-US" altLang="zh-CN" dirty="0" err="1"/>
+              <a:t>github</a:t>
+            </a:r>
+            <a:r>
+              <a:rPr lang="en-US" altLang="zh-CN" dirty="0"/>
+              <a:t> repo</a:t>
+            </a:r>
+            <a:endParaRPr lang="zh-CN" altLang="en-US" dirty="0"/>
           </a:p>
         </p:txBody>
       </p:sp>
@@ -7087,7 +7103,7 @@
         </p:nvSpPr>
         <p:spPr>
           <a:xfrm>
-            <a:off x="9040396" y="6469828"/>
+            <a:off x="9040396" y="6469282"/>
             <a:ext cx="3080208" cy="332590"/>
           </a:xfrm>
           <a:prstGeom prst="rect">
@@ -7325,6 +7341,99 @@
               <a:t>6</a:t>
             </a:r>
             <a:endParaRPr lang="zh-CN" altLang="en-US" sz="1200" dirty="0"/>
+          </a:p>
+        </p:txBody>
+      </p:sp>
+      <p:sp>
+        <p:nvSpPr>
+          <p:cNvPr id="18" name="文本框 17">
+            <a:extLst>
+              <a:ext uri="{FF2B5EF4-FFF2-40B4-BE49-F238E27FC236}">
+                <a16:creationId xmlns:a16="http://schemas.microsoft.com/office/drawing/2014/main" id="{01BE2EE4-9370-3384-0C5C-F5475CF6EB39}"/>
+              </a:ext>
+            </a:extLst>
+          </p:cNvPr>
+          <p:cNvSpPr txBox="1"/>
+          <p:nvPr/>
+        </p:nvSpPr>
+        <p:spPr>
+          <a:xfrm>
+            <a:off x="6323694" y="5953357"/>
+            <a:ext cx="2657036" cy="646331"/>
+          </a:xfrm>
+          <a:prstGeom prst="rect">
+            <a:avLst/>
+          </a:prstGeom>
+          <a:noFill/>
+        </p:spPr>
+        <p:txBody>
+          <a:bodyPr wrap="square" rtlCol="0">
+            <a:spAutoFit/>
+          </a:bodyPr>
+          <a:lstStyle/>
+          <a:p>
+            <a:r>
+              <a:rPr lang="en-US" altLang="zh-CN" dirty="0"/>
+              <a:t>7.</a:t>
+            </a:r>
+            <a:r>
+              <a:rPr lang="zh-CN" altLang="en-US" dirty="0"/>
+              <a:t>是一个可交互的世界，</a:t>
+            </a:r>
+            <a:endParaRPr lang="en-US" altLang="zh-CN" dirty="0"/>
+          </a:p>
+          <a:p>
+            <a:r>
+              <a:rPr lang="zh-CN" altLang="en-US" dirty="0"/>
+              <a:t>（文件夹）非单个文件</a:t>
+            </a:r>
+          </a:p>
+        </p:txBody>
+      </p:sp>
+      <p:sp>
+        <p:nvSpPr>
+          <p:cNvPr id="19" name="文本框 18">
+            <a:extLst>
+              <a:ext uri="{FF2B5EF4-FFF2-40B4-BE49-F238E27FC236}">
+                <a16:creationId xmlns:a16="http://schemas.microsoft.com/office/drawing/2014/main" id="{6B16AB4C-45CF-6116-4728-3E9F3F381D9D}"/>
+              </a:ext>
+            </a:extLst>
+          </p:cNvPr>
+          <p:cNvSpPr txBox="1"/>
+          <p:nvPr/>
+        </p:nvSpPr>
+        <p:spPr>
+          <a:xfrm>
+            <a:off x="9156719" y="6468290"/>
+            <a:ext cx="3035281" cy="369332"/>
+          </a:xfrm>
+          <a:prstGeom prst="rect">
+            <a:avLst/>
+          </a:prstGeom>
+          <a:noFill/>
+        </p:spPr>
+        <p:txBody>
+          <a:bodyPr wrap="square" rtlCol="0">
+            <a:spAutoFit/>
+          </a:bodyPr>
+          <a:lstStyle/>
+          <a:p>
+            <a:r>
+              <a:rPr lang="en-US" altLang="zh-CN" dirty="0"/>
+              <a:t>6.</a:t>
+            </a:r>
+            <a:r>
+              <a:rPr lang="zh-CN" altLang="en-US" dirty="0"/>
+              <a:t>也是</a:t>
+            </a:r>
+            <a:r>
+              <a:rPr lang="en-US" altLang="zh-CN" dirty="0"/>
+              <a:t>AME ADMIN</a:t>
+            </a:r>
+            <a:r>
+              <a:rPr lang="zh-CN" altLang="en-US" dirty="0"/>
+              <a:t>的主程序</a:t>
+            </a:r>
           </a:p>
         </p:txBody>
       </p:sp>

</xml_diff>